<commit_message>
docs: finalize slide presentation file
</commit_message>
<xml_diff>
--- a/dpi-ls-cost.pptx
+++ b/dpi-ls-cost.pptx
@@ -5,14 +5,14 @@
     <p:sldMasterId id="2147483648" r:id="rId1"/>
   </p:sldMasterIdLst>
   <p:sldIdLst>
-    <p:sldId id="256" r:id="rId7"/>
-    <p:sldId id="257" r:id="rId8"/>
-    <p:sldId id="258" r:id="rId9"/>
-    <p:sldId id="259" r:id="rId10"/>
-    <p:sldId id="260" r:id="rId11"/>
-    <p:sldId id="261" r:id="rId12"/>
+    <p:sldId id="256" r:id="rId2"/>
+    <p:sldId id="257" r:id="rId3"/>
+    <p:sldId id="258" r:id="rId4"/>
+    <p:sldId id="259" r:id="rId5"/>
+    <p:sldId id="260" r:id="rId6"/>
+    <p:sldId id="261" r:id="rId7"/>
   </p:sldIdLst>
-  <p:sldSz cx="12188952" cy="6858000" type="screen4x3"/>
+  <p:sldSz cx="12188825" cy="6858000"/>
   <p:notesSz cx="6858000" cy="9144000"/>
   <p:defaultTextStyle>
     <a:defPPr>
@@ -109,6 +109,22 @@
       </a:defRPr>
     </a:lvl9pPr>
   </p:defaultTextStyle>
+  <p:extLst>
+    <p:ext uri="{EFAFB233-063F-42B5-8137-9DF3F51BA10A}">
+      <p15:sldGuideLst xmlns:p15="http://schemas.microsoft.com/office/powerpoint/2012/main">
+        <p15:guide id="1" orient="horz" pos="2160">
+          <p15:clr>
+            <a:srgbClr val="A4A3A4"/>
+          </p15:clr>
+        </p15:guide>
+        <p15:guide id="2" pos="2880">
+          <p15:clr>
+            <a:srgbClr val="A4A3A4"/>
+          </p15:clr>
+        </p15:guide>
+      </p15:sldGuideLst>
+    </p:ext>
+  </p:extLst>
 </p:presentation>
 </file>
 
@@ -150,10 +166,9 @@
           <a:lstStyle/>
           <a:p>
             <a:r>
-              <a:rPr lang="en-US" smtClean="0"/>
+              <a:rPr lang="en-US"/>
               <a:t>Click to edit Master title style</a:t>
             </a:r>
-            <a:endParaRPr lang="en-US"/>
           </a:p>
         </p:txBody>
       </p:sp>
@@ -269,10 +284,9 @@
           </a:lstStyle>
           <a:p>
             <a:r>
-              <a:rPr lang="en-US" smtClean="0"/>
+              <a:rPr lang="en-US"/>
               <a:t>Click to edit Master subtitle style</a:t>
             </a:r>
-            <a:endParaRPr lang="en-US"/>
           </a:p>
         </p:txBody>
       </p:sp>
@@ -293,7 +307,7 @@
           <a:p>
             <a:fld id="{5BCAD085-E8A6-8845-BD4E-CB4CCA059FC4}" type="datetimeFigureOut">
               <a:rPr lang="en-US" smtClean="0"/>
-              <a:t>1/27/13</a:t>
+              <a:t>6/26/2026</a:t>
             </a:fld>
             <a:endParaRPr lang="en-US"/>
           </a:p>
@@ -387,10 +401,9 @@
           <a:lstStyle/>
           <a:p>
             <a:r>
-              <a:rPr lang="en-US" smtClean="0"/>
+              <a:rPr lang="en-US"/>
               <a:t>Click to edit Master title style</a:t>
             </a:r>
-            <a:endParaRPr lang="en-US"/>
           </a:p>
         </p:txBody>
       </p:sp>
@@ -411,38 +424,37 @@
           <a:p>
             <a:pPr lvl="0"/>
             <a:r>
-              <a:rPr lang="en-US" smtClean="0"/>
+              <a:rPr lang="en-US"/>
               <a:t>Click to edit Master text styles</a:t>
             </a:r>
           </a:p>
           <a:p>
             <a:pPr lvl="1"/>
             <a:r>
-              <a:rPr lang="en-US" smtClean="0"/>
+              <a:rPr lang="en-US"/>
               <a:t>Second level</a:t>
             </a:r>
           </a:p>
           <a:p>
             <a:pPr lvl="2"/>
             <a:r>
-              <a:rPr lang="en-US" smtClean="0"/>
+              <a:rPr lang="en-US"/>
               <a:t>Third level</a:t>
             </a:r>
           </a:p>
           <a:p>
             <a:pPr lvl="3"/>
             <a:r>
-              <a:rPr lang="en-US" smtClean="0"/>
+              <a:rPr lang="en-US"/>
               <a:t>Fourth level</a:t>
             </a:r>
           </a:p>
           <a:p>
             <a:pPr lvl="4"/>
             <a:r>
-              <a:rPr lang="en-US" smtClean="0"/>
+              <a:rPr lang="en-US"/>
               <a:t>Fifth level</a:t>
             </a:r>
-            <a:endParaRPr lang="en-US"/>
           </a:p>
         </p:txBody>
       </p:sp>
@@ -463,7 +475,7 @@
           <a:p>
             <a:fld id="{5BCAD085-E8A6-8845-BD4E-CB4CCA059FC4}" type="datetimeFigureOut">
               <a:rPr lang="en-US" smtClean="0"/>
-              <a:t>1/27/13</a:t>
+              <a:t>6/26/2026</a:t>
             </a:fld>
             <a:endParaRPr lang="en-US"/>
           </a:p>
@@ -562,10 +574,9 @@
           <a:lstStyle/>
           <a:p>
             <a:r>
-              <a:rPr lang="en-US" smtClean="0"/>
+              <a:rPr lang="en-US"/>
               <a:t>Click to edit Master title style</a:t>
             </a:r>
-            <a:endParaRPr lang="en-US"/>
           </a:p>
         </p:txBody>
       </p:sp>
@@ -591,38 +602,37 @@
           <a:p>
             <a:pPr lvl="0"/>
             <a:r>
-              <a:rPr lang="en-US" smtClean="0"/>
+              <a:rPr lang="en-US"/>
               <a:t>Click to edit Master text styles</a:t>
             </a:r>
           </a:p>
           <a:p>
             <a:pPr lvl="1"/>
             <a:r>
-              <a:rPr lang="en-US" smtClean="0"/>
+              <a:rPr lang="en-US"/>
               <a:t>Second level</a:t>
             </a:r>
           </a:p>
           <a:p>
             <a:pPr lvl="2"/>
             <a:r>
-              <a:rPr lang="en-US" smtClean="0"/>
+              <a:rPr lang="en-US"/>
               <a:t>Third level</a:t>
             </a:r>
           </a:p>
           <a:p>
             <a:pPr lvl="3"/>
             <a:r>
-              <a:rPr lang="en-US" smtClean="0"/>
+              <a:rPr lang="en-US"/>
               <a:t>Fourth level</a:t>
             </a:r>
           </a:p>
           <a:p>
             <a:pPr lvl="4"/>
             <a:r>
-              <a:rPr lang="en-US" smtClean="0"/>
+              <a:rPr lang="en-US"/>
               <a:t>Fifth level</a:t>
             </a:r>
-            <a:endParaRPr lang="en-US"/>
           </a:p>
         </p:txBody>
       </p:sp>
@@ -643,7 +653,7 @@
           <a:p>
             <a:fld id="{5BCAD085-E8A6-8845-BD4E-CB4CCA059FC4}" type="datetimeFigureOut">
               <a:rPr lang="en-US" smtClean="0"/>
-              <a:t>1/27/13</a:t>
+              <a:t>6/26/2026</a:t>
             </a:fld>
             <a:endParaRPr lang="en-US"/>
           </a:p>
@@ -737,10 +747,9 @@
           <a:lstStyle/>
           <a:p>
             <a:r>
-              <a:rPr lang="en-US" smtClean="0"/>
+              <a:rPr lang="en-US"/>
               <a:t>Click to edit Master title style</a:t>
             </a:r>
-            <a:endParaRPr lang="en-US"/>
           </a:p>
         </p:txBody>
       </p:sp>
@@ -761,38 +770,37 @@
           <a:p>
             <a:pPr lvl="0"/>
             <a:r>
-              <a:rPr lang="en-US" smtClean="0"/>
+              <a:rPr lang="en-US"/>
               <a:t>Click to edit Master text styles</a:t>
             </a:r>
           </a:p>
           <a:p>
             <a:pPr lvl="1"/>
             <a:r>
-              <a:rPr lang="en-US" smtClean="0"/>
+              <a:rPr lang="en-US"/>
               <a:t>Second level</a:t>
             </a:r>
           </a:p>
           <a:p>
             <a:pPr lvl="2"/>
             <a:r>
-              <a:rPr lang="en-US" smtClean="0"/>
+              <a:rPr lang="en-US"/>
               <a:t>Third level</a:t>
             </a:r>
           </a:p>
           <a:p>
             <a:pPr lvl="3"/>
             <a:r>
-              <a:rPr lang="en-US" smtClean="0"/>
+              <a:rPr lang="en-US"/>
               <a:t>Fourth level</a:t>
             </a:r>
           </a:p>
           <a:p>
             <a:pPr lvl="4"/>
             <a:r>
-              <a:rPr lang="en-US" smtClean="0"/>
+              <a:rPr lang="en-US"/>
               <a:t>Fifth level</a:t>
             </a:r>
-            <a:endParaRPr lang="en-US"/>
           </a:p>
         </p:txBody>
       </p:sp>
@@ -813,7 +821,7 @@
           <a:p>
             <a:fld id="{5BCAD085-E8A6-8845-BD4E-CB4CCA059FC4}" type="datetimeFigureOut">
               <a:rPr lang="en-US" smtClean="0"/>
-              <a:t>1/27/13</a:t>
+              <a:t>6/26/2026</a:t>
             </a:fld>
             <a:endParaRPr lang="en-US"/>
           </a:p>
@@ -916,10 +924,9 @@
           </a:lstStyle>
           <a:p>
             <a:r>
-              <a:rPr lang="en-US" smtClean="0"/>
+              <a:rPr lang="en-US"/>
               <a:t>Click to edit Master title style</a:t>
             </a:r>
-            <a:endParaRPr lang="en-US"/>
           </a:p>
         </p:txBody>
       </p:sp>
@@ -1036,7 +1043,7 @@
           <a:p>
             <a:pPr lvl="0"/>
             <a:r>
-              <a:rPr lang="en-US" smtClean="0"/>
+              <a:rPr lang="en-US"/>
               <a:t>Click to edit Master text styles</a:t>
             </a:r>
           </a:p>
@@ -1059,7 +1066,7 @@
           <a:p>
             <a:fld id="{5BCAD085-E8A6-8845-BD4E-CB4CCA059FC4}" type="datetimeFigureOut">
               <a:rPr lang="en-US" smtClean="0"/>
-              <a:t>1/27/13</a:t>
+              <a:t>6/26/2026</a:t>
             </a:fld>
             <a:endParaRPr lang="en-US"/>
           </a:p>
@@ -1153,10 +1160,9 @@
           <a:lstStyle/>
           <a:p>
             <a:r>
-              <a:rPr lang="en-US" smtClean="0"/>
+              <a:rPr lang="en-US"/>
               <a:t>Click to edit Master title style</a:t>
             </a:r>
-            <a:endParaRPr lang="en-US"/>
           </a:p>
         </p:txBody>
       </p:sp>
@@ -1210,38 +1216,37 @@
           <a:p>
             <a:pPr lvl="0"/>
             <a:r>
-              <a:rPr lang="en-US" smtClean="0"/>
+              <a:rPr lang="en-US"/>
               <a:t>Click to edit Master text styles</a:t>
             </a:r>
           </a:p>
           <a:p>
             <a:pPr lvl="1"/>
             <a:r>
-              <a:rPr lang="en-US" smtClean="0"/>
+              <a:rPr lang="en-US"/>
               <a:t>Second level</a:t>
             </a:r>
           </a:p>
           <a:p>
             <a:pPr lvl="2"/>
             <a:r>
-              <a:rPr lang="en-US" smtClean="0"/>
+              <a:rPr lang="en-US"/>
               <a:t>Third level</a:t>
             </a:r>
           </a:p>
           <a:p>
             <a:pPr lvl="3"/>
             <a:r>
-              <a:rPr lang="en-US" smtClean="0"/>
+              <a:rPr lang="en-US"/>
               <a:t>Fourth level</a:t>
             </a:r>
           </a:p>
           <a:p>
             <a:pPr lvl="4"/>
             <a:r>
-              <a:rPr lang="en-US" smtClean="0"/>
+              <a:rPr lang="en-US"/>
               <a:t>Fifth level</a:t>
             </a:r>
-            <a:endParaRPr lang="en-US"/>
           </a:p>
         </p:txBody>
       </p:sp>
@@ -1295,38 +1300,37 @@
           <a:p>
             <a:pPr lvl="0"/>
             <a:r>
-              <a:rPr lang="en-US" smtClean="0"/>
+              <a:rPr lang="en-US"/>
               <a:t>Click to edit Master text styles</a:t>
             </a:r>
           </a:p>
           <a:p>
             <a:pPr lvl="1"/>
             <a:r>
-              <a:rPr lang="en-US" smtClean="0"/>
+              <a:rPr lang="en-US"/>
               <a:t>Second level</a:t>
             </a:r>
           </a:p>
           <a:p>
             <a:pPr lvl="2"/>
             <a:r>
-              <a:rPr lang="en-US" smtClean="0"/>
+              <a:rPr lang="en-US"/>
               <a:t>Third level</a:t>
             </a:r>
           </a:p>
           <a:p>
             <a:pPr lvl="3"/>
             <a:r>
-              <a:rPr lang="en-US" smtClean="0"/>
+              <a:rPr lang="en-US"/>
               <a:t>Fourth level</a:t>
             </a:r>
           </a:p>
           <a:p>
             <a:pPr lvl="4"/>
             <a:r>
-              <a:rPr lang="en-US" smtClean="0"/>
+              <a:rPr lang="en-US"/>
               <a:t>Fifth level</a:t>
             </a:r>
-            <a:endParaRPr lang="en-US"/>
           </a:p>
         </p:txBody>
       </p:sp>
@@ -1347,7 +1351,7 @@
           <a:p>
             <a:fld id="{5BCAD085-E8A6-8845-BD4E-CB4CCA059FC4}" type="datetimeFigureOut">
               <a:rPr lang="en-US" smtClean="0"/>
-              <a:t>1/27/13</a:t>
+              <a:t>6/26/2026</a:t>
             </a:fld>
             <a:endParaRPr lang="en-US"/>
           </a:p>
@@ -1445,10 +1449,9 @@
           </a:lstStyle>
           <a:p>
             <a:r>
-              <a:rPr lang="en-US" smtClean="0"/>
+              <a:rPr lang="en-US"/>
               <a:t>Click to edit Master title style</a:t>
             </a:r>
-            <a:endParaRPr lang="en-US"/>
           </a:p>
         </p:txBody>
       </p:sp>
@@ -1511,7 +1514,7 @@
           <a:p>
             <a:pPr lvl="0"/>
             <a:r>
-              <a:rPr lang="en-US" smtClean="0"/>
+              <a:rPr lang="en-US"/>
               <a:t>Click to edit Master text styles</a:t>
             </a:r>
           </a:p>
@@ -1567,38 +1570,37 @@
           <a:p>
             <a:pPr lvl="0"/>
             <a:r>
-              <a:rPr lang="en-US" smtClean="0"/>
+              <a:rPr lang="en-US"/>
               <a:t>Click to edit Master text styles</a:t>
             </a:r>
           </a:p>
           <a:p>
             <a:pPr lvl="1"/>
             <a:r>
-              <a:rPr lang="en-US" smtClean="0"/>
+              <a:rPr lang="en-US"/>
               <a:t>Second level</a:t>
             </a:r>
           </a:p>
           <a:p>
             <a:pPr lvl="2"/>
             <a:r>
-              <a:rPr lang="en-US" smtClean="0"/>
+              <a:rPr lang="en-US"/>
               <a:t>Third level</a:t>
             </a:r>
           </a:p>
           <a:p>
             <a:pPr lvl="3"/>
             <a:r>
-              <a:rPr lang="en-US" smtClean="0"/>
+              <a:rPr lang="en-US"/>
               <a:t>Fourth level</a:t>
             </a:r>
           </a:p>
           <a:p>
             <a:pPr lvl="4"/>
             <a:r>
-              <a:rPr lang="en-US" smtClean="0"/>
+              <a:rPr lang="en-US"/>
               <a:t>Fifth level</a:t>
             </a:r>
-            <a:endParaRPr lang="en-US"/>
           </a:p>
         </p:txBody>
       </p:sp>
@@ -1661,7 +1663,7 @@
           <a:p>
             <a:pPr lvl="0"/>
             <a:r>
-              <a:rPr lang="en-US" smtClean="0"/>
+              <a:rPr lang="en-US"/>
               <a:t>Click to edit Master text styles</a:t>
             </a:r>
           </a:p>
@@ -1717,38 +1719,37 @@
           <a:p>
             <a:pPr lvl="0"/>
             <a:r>
-              <a:rPr lang="en-US" smtClean="0"/>
+              <a:rPr lang="en-US"/>
               <a:t>Click to edit Master text styles</a:t>
             </a:r>
           </a:p>
           <a:p>
             <a:pPr lvl="1"/>
             <a:r>
-              <a:rPr lang="en-US" smtClean="0"/>
+              <a:rPr lang="en-US"/>
               <a:t>Second level</a:t>
             </a:r>
           </a:p>
           <a:p>
             <a:pPr lvl="2"/>
             <a:r>
-              <a:rPr lang="en-US" smtClean="0"/>
+              <a:rPr lang="en-US"/>
               <a:t>Third level</a:t>
             </a:r>
           </a:p>
           <a:p>
             <a:pPr lvl="3"/>
             <a:r>
-              <a:rPr lang="en-US" smtClean="0"/>
+              <a:rPr lang="en-US"/>
               <a:t>Fourth level</a:t>
             </a:r>
           </a:p>
           <a:p>
             <a:pPr lvl="4"/>
             <a:r>
-              <a:rPr lang="en-US" smtClean="0"/>
+              <a:rPr lang="en-US"/>
               <a:t>Fifth level</a:t>
             </a:r>
-            <a:endParaRPr lang="en-US"/>
           </a:p>
         </p:txBody>
       </p:sp>
@@ -1769,7 +1770,7 @@
           <a:p>
             <a:fld id="{5BCAD085-E8A6-8845-BD4E-CB4CCA059FC4}" type="datetimeFigureOut">
               <a:rPr lang="en-US" smtClean="0"/>
-              <a:t>1/27/13</a:t>
+              <a:t>6/26/2026</a:t>
             </a:fld>
             <a:endParaRPr lang="en-US"/>
           </a:p>
@@ -1863,10 +1864,9 @@
           <a:lstStyle/>
           <a:p>
             <a:r>
-              <a:rPr lang="en-US" smtClean="0"/>
+              <a:rPr lang="en-US"/>
               <a:t>Click to edit Master title style</a:t>
             </a:r>
-            <a:endParaRPr lang="en-US"/>
           </a:p>
         </p:txBody>
       </p:sp>
@@ -1887,7 +1887,7 @@
           <a:p>
             <a:fld id="{5BCAD085-E8A6-8845-BD4E-CB4CCA059FC4}" type="datetimeFigureOut">
               <a:rPr lang="en-US" smtClean="0"/>
-              <a:t>1/27/13</a:t>
+              <a:t>6/26/2026</a:t>
             </a:fld>
             <a:endParaRPr lang="en-US"/>
           </a:p>
@@ -1982,7 +1982,7 @@
           <a:p>
             <a:fld id="{5BCAD085-E8A6-8845-BD4E-CB4CCA059FC4}" type="datetimeFigureOut">
               <a:rPr lang="en-US" smtClean="0"/>
-              <a:t>1/27/13</a:t>
+              <a:t>6/26/2026</a:t>
             </a:fld>
             <a:endParaRPr lang="en-US"/>
           </a:p>
@@ -2085,10 +2085,9 @@
           </a:lstStyle>
           <a:p>
             <a:r>
-              <a:rPr lang="en-US" smtClean="0"/>
+              <a:rPr lang="en-US"/>
               <a:t>Click to edit Master title style</a:t>
             </a:r>
-            <a:endParaRPr lang="en-US"/>
           </a:p>
         </p:txBody>
       </p:sp>
@@ -2142,38 +2141,37 @@
           <a:p>
             <a:pPr lvl="0"/>
             <a:r>
-              <a:rPr lang="en-US" smtClean="0"/>
+              <a:rPr lang="en-US"/>
               <a:t>Click to edit Master text styles</a:t>
             </a:r>
           </a:p>
           <a:p>
             <a:pPr lvl="1"/>
             <a:r>
-              <a:rPr lang="en-US" smtClean="0"/>
+              <a:rPr lang="en-US"/>
               <a:t>Second level</a:t>
             </a:r>
           </a:p>
           <a:p>
             <a:pPr lvl="2"/>
             <a:r>
-              <a:rPr lang="en-US" smtClean="0"/>
+              <a:rPr lang="en-US"/>
               <a:t>Third level</a:t>
             </a:r>
           </a:p>
           <a:p>
             <a:pPr lvl="3"/>
             <a:r>
-              <a:rPr lang="en-US" smtClean="0"/>
+              <a:rPr lang="en-US"/>
               <a:t>Fourth level</a:t>
             </a:r>
           </a:p>
           <a:p>
             <a:pPr lvl="4"/>
             <a:r>
-              <a:rPr lang="en-US" smtClean="0"/>
+              <a:rPr lang="en-US"/>
               <a:t>Fifth level</a:t>
             </a:r>
-            <a:endParaRPr lang="en-US"/>
           </a:p>
         </p:txBody>
       </p:sp>
@@ -2236,7 +2234,7 @@
           <a:p>
             <a:pPr lvl="0"/>
             <a:r>
-              <a:rPr lang="en-US" smtClean="0"/>
+              <a:rPr lang="en-US"/>
               <a:t>Click to edit Master text styles</a:t>
             </a:r>
           </a:p>
@@ -2259,7 +2257,7 @@
           <a:p>
             <a:fld id="{5BCAD085-E8A6-8845-BD4E-CB4CCA059FC4}" type="datetimeFigureOut">
               <a:rPr lang="en-US" smtClean="0"/>
-              <a:t>1/27/13</a:t>
+              <a:t>6/26/2026</a:t>
             </a:fld>
             <a:endParaRPr lang="en-US"/>
           </a:p>
@@ -2362,10 +2360,9 @@
           </a:lstStyle>
           <a:p>
             <a:r>
-              <a:rPr lang="en-US" smtClean="0"/>
+              <a:rPr lang="en-US"/>
               <a:t>Click to edit Master title style</a:t>
             </a:r>
-            <a:endParaRPr lang="en-US"/>
           </a:p>
         </p:txBody>
       </p:sp>
@@ -2489,7 +2486,7 @@
           <a:p>
             <a:pPr lvl="0"/>
             <a:r>
-              <a:rPr lang="en-US" smtClean="0"/>
+              <a:rPr lang="en-US"/>
               <a:t>Click to edit Master text styles</a:t>
             </a:r>
           </a:p>
@@ -2512,7 +2509,7 @@
           <a:p>
             <a:fld id="{5BCAD085-E8A6-8845-BD4E-CB4CCA059FC4}" type="datetimeFigureOut">
               <a:rPr lang="en-US" smtClean="0"/>
-              <a:t>1/27/13</a:t>
+              <a:t>6/26/2026</a:t>
             </a:fld>
             <a:endParaRPr lang="en-US"/>
           </a:p>
@@ -2621,10 +2618,9 @@
           <a:lstStyle/>
           <a:p>
             <a:r>
-              <a:rPr lang="en-US" smtClean="0"/>
+              <a:rPr lang="en-US"/>
               <a:t>Click to edit Master title style</a:t>
             </a:r>
-            <a:endParaRPr lang="en-US"/>
           </a:p>
         </p:txBody>
       </p:sp>
@@ -2655,38 +2651,37 @@
           <a:p>
             <a:pPr lvl="0"/>
             <a:r>
-              <a:rPr lang="en-US" smtClean="0"/>
+              <a:rPr lang="en-US"/>
               <a:t>Click to edit Master text styles</a:t>
             </a:r>
           </a:p>
           <a:p>
             <a:pPr lvl="1"/>
             <a:r>
-              <a:rPr lang="en-US" smtClean="0"/>
+              <a:rPr lang="en-US"/>
               <a:t>Second level</a:t>
             </a:r>
           </a:p>
           <a:p>
             <a:pPr lvl="2"/>
             <a:r>
-              <a:rPr lang="en-US" smtClean="0"/>
+              <a:rPr lang="en-US"/>
               <a:t>Third level</a:t>
             </a:r>
           </a:p>
           <a:p>
             <a:pPr lvl="3"/>
             <a:r>
-              <a:rPr lang="en-US" smtClean="0"/>
+              <a:rPr lang="en-US"/>
               <a:t>Fourth level</a:t>
             </a:r>
           </a:p>
           <a:p>
             <a:pPr lvl="4"/>
             <a:r>
-              <a:rPr lang="en-US" smtClean="0"/>
+              <a:rPr lang="en-US"/>
               <a:t>Fifth level</a:t>
             </a:r>
-            <a:endParaRPr lang="en-US"/>
           </a:p>
         </p:txBody>
       </p:sp>
@@ -2725,7 +2720,7 @@
           <a:p>
             <a:fld id="{5BCAD085-E8A6-8845-BD4E-CB4CCA059FC4}" type="datetimeFigureOut">
               <a:rPr lang="en-US" smtClean="0"/>
-              <a:t>1/27/13</a:t>
+              <a:t>6/26/2026</a:t>
             </a:fld>
             <a:endParaRPr lang="en-US"/>
           </a:p>
@@ -3084,7 +3079,7 @@
 </file>
 
 <file path=ppt/slides/slide1.xml><?xml version="1.0" encoding="utf-8"?>
-<p:sld xmlns:a="http://schemas.openxmlformats.org/drawingml/2006/main" xmlns:p="http://schemas.openxmlformats.org/presentationml/2006/main" xmlns:r="http://schemas.openxmlformats.org/officeDocument/2006/relationships">
+<p:sld xmlns:a="http://schemas.openxmlformats.org/drawingml/2006/main" xmlns:r="http://schemas.openxmlformats.org/officeDocument/2006/relationships" xmlns:p="http://schemas.openxmlformats.org/presentationml/2006/main">
   <p:cSld>
     <p:bg>
       <p:bgPr>
@@ -3100,7 +3095,14 @@
         <p:cNvGrpSpPr/>
         <p:nvPr/>
       </p:nvGrpSpPr>
-      <p:grpSpPr/>
+      <p:grpSpPr>
+        <a:xfrm>
+          <a:off x="0" y="0"/>
+          <a:ext cx="0" cy="0"/>
+          <a:chOff x="0" y="0"/>
+          <a:chExt cx="0" cy="0"/>
+        </a:xfrm>
+      </p:grpSpPr>
       <p:sp>
         <p:nvSpPr>
           <p:cNvPr id="2" name="Rectangle 1"/>
@@ -3141,6 +3143,7 @@
           <a:lstStyle/>
           <a:p>
             <a:pPr algn="ctr"/>
+            <a:endParaRPr/>
           </a:p>
         </p:txBody>
       </p:sp>
@@ -3196,74 +3199,6 @@
           </a:p>
         </p:txBody>
       </p:sp>
-      <p:sp>
-        <p:nvSpPr>
-          <p:cNvPr id="4" name="TextBox 3"/>
-          <p:cNvSpPr txBox="1"/>
-          <p:nvPr/>
-        </p:nvSpPr>
-        <p:spPr>
-          <a:xfrm>
-            <a:off x="1097280" y="4114800"/>
-            <a:ext cx="10058400" cy="1828800"/>
-          </a:xfrm>
-          <a:prstGeom prst="rect">
-            <a:avLst/>
-          </a:prstGeom>
-          <a:noFill/>
-        </p:spPr>
-        <p:txBody>
-          <a:bodyPr wrap="square">
-            <a:spAutoFit/>
-          </a:bodyPr>
-          <a:lstStyle/>
-          <a:p>
-            <a:pPr>
-              <a:defRPr sz="1600">
-                <a:solidFill>
-                  <a:srgbClr val="94A3B8"/>
-                </a:solidFill>
-                <a:latin typeface="Arial"/>
-              </a:defRPr>
-            </a:pPr>
-            <a:r>
-              <a:t>Cost Traceability, Real-Time Telemetry &amp; Core Scoring Validation</a:t>
-            </a:r>
-          </a:p>
-          <a:p>
-            <a:pPr>
-              <a:spcBef>
-                <a:spcPts val="800"/>
-              </a:spcBef>
-              <a:defRPr sz="1400" b="1">
-                <a:solidFill>
-                  <a:srgbClr val="10B981"/>
-                </a:solidFill>
-                <a:latin typeface="Arial"/>
-              </a:defRPr>
-            </a:pPr>
-            <a:r>
-              <a:t>Presented to: Wipro, Deloitte, JP Morgan, EY, PwC, Infosys &amp; Regeneron</a:t>
-            </a:r>
-          </a:p>
-          <a:p>
-            <a:pPr>
-              <a:spcBef>
-                <a:spcPts val="500"/>
-              </a:spcBef>
-              <a:defRPr sz="1200">
-                <a:solidFill>
-                  <a:srgbClr val="FFFFFF"/>
-                </a:solidFill>
-                <a:latin typeface="Arial"/>
-              </a:defRPr>
-            </a:pPr>
-            <a:r>
-              <a:t>Executive Briefing: CEO, Ranga (CEO), Phani (Lead)</a:t>
-            </a:r>
-          </a:p>
-        </p:txBody>
-      </p:sp>
     </p:spTree>
   </p:cSld>
   <p:clrMapOvr>
@@ -3273,7 +3208,7 @@
 </file>
 
 <file path=ppt/slides/slide2.xml><?xml version="1.0" encoding="utf-8"?>
-<p:sld xmlns:a="http://schemas.openxmlformats.org/drawingml/2006/main" xmlns:p="http://schemas.openxmlformats.org/presentationml/2006/main" xmlns:r="http://schemas.openxmlformats.org/officeDocument/2006/relationships">
+<p:sld xmlns:a="http://schemas.openxmlformats.org/drawingml/2006/main" xmlns:r="http://schemas.openxmlformats.org/officeDocument/2006/relationships" xmlns:p="http://schemas.openxmlformats.org/presentationml/2006/main">
   <p:cSld>
     <p:bg>
       <p:bgPr>
@@ -3289,7 +3224,14 @@
         <p:cNvGrpSpPr/>
         <p:nvPr/>
       </p:nvGrpSpPr>
-      <p:grpSpPr/>
+      <p:grpSpPr>
+        <a:xfrm>
+          <a:off x="0" y="0"/>
+          <a:ext cx="0" cy="0"/>
+          <a:chOff x="0" y="0"/>
+          <a:chExt cx="0" cy="0"/>
+        </a:xfrm>
+      </p:grpSpPr>
       <p:sp>
         <p:nvSpPr>
           <p:cNvPr id="2" name="TextBox 1"/>
@@ -3497,7 +3439,7 @@
 </file>
 
 <file path=ppt/slides/slide3.xml><?xml version="1.0" encoding="utf-8"?>
-<p:sld xmlns:a="http://schemas.openxmlformats.org/drawingml/2006/main" xmlns:p="http://schemas.openxmlformats.org/presentationml/2006/main" xmlns:r="http://schemas.openxmlformats.org/officeDocument/2006/relationships">
+<p:sld xmlns:a="http://schemas.openxmlformats.org/drawingml/2006/main" xmlns:r="http://schemas.openxmlformats.org/officeDocument/2006/relationships" xmlns:p="http://schemas.openxmlformats.org/presentationml/2006/main">
   <p:cSld>
     <p:bg>
       <p:bgPr>
@@ -3513,7 +3455,14 @@
         <p:cNvGrpSpPr/>
         <p:nvPr/>
       </p:nvGrpSpPr>
-      <p:grpSpPr/>
+      <p:grpSpPr>
+        <a:xfrm>
+          <a:off x="0" y="0"/>
+          <a:ext cx="0" cy="0"/>
+          <a:chOff x="0" y="0"/>
+          <a:chExt cx="0" cy="0"/>
+        </a:xfrm>
+      </p:grpSpPr>
       <p:sp>
         <p:nvSpPr>
           <p:cNvPr id="2" name="TextBox 1"/>
@@ -3655,11 +3604,41 @@
                 <a:tableStyleId>{5C22544A-7EE6-4342-B048-85BDC9FD1C3A}</a:tableStyleId>
               </a:tblPr>
               <a:tblGrid>
-                <a:gridCol w="457200"/>
-                <a:gridCol w="1645920"/>
-                <a:gridCol w="2926080"/>
-                <a:gridCol w="2011680"/>
-                <a:gridCol w="3657600"/>
+                <a:gridCol w="457200">
+                  <a:extLst>
+                    <a:ext uri="{9D8B030D-6E8A-4147-A177-3AD203B41FA5}">
+                      <a16:colId xmlns:a16="http://schemas.microsoft.com/office/drawing/2014/main" val="20000"/>
+                    </a:ext>
+                  </a:extLst>
+                </a:gridCol>
+                <a:gridCol w="1645920">
+                  <a:extLst>
+                    <a:ext uri="{9D8B030D-6E8A-4147-A177-3AD203B41FA5}">
+                      <a16:colId xmlns:a16="http://schemas.microsoft.com/office/drawing/2014/main" val="20001"/>
+                    </a:ext>
+                  </a:extLst>
+                </a:gridCol>
+                <a:gridCol w="2926080">
+                  <a:extLst>
+                    <a:ext uri="{9D8B030D-6E8A-4147-A177-3AD203B41FA5}">
+                      <a16:colId xmlns:a16="http://schemas.microsoft.com/office/drawing/2014/main" val="20002"/>
+                    </a:ext>
+                  </a:extLst>
+                </a:gridCol>
+                <a:gridCol w="2011680">
+                  <a:extLst>
+                    <a:ext uri="{9D8B030D-6E8A-4147-A177-3AD203B41FA5}">
+                      <a16:colId xmlns:a16="http://schemas.microsoft.com/office/drawing/2014/main" val="20003"/>
+                    </a:ext>
+                  </a:extLst>
+                </a:gridCol>
+                <a:gridCol w="3657600">
+                  <a:extLst>
+                    <a:ext uri="{9D8B030D-6E8A-4147-A177-3AD203B41FA5}">
+                      <a16:colId xmlns:a16="http://schemas.microsoft.com/office/drawing/2014/main" val="20004"/>
+                    </a:ext>
+                  </a:extLst>
+                </a:gridCol>
               </a:tblGrid>
               <a:tr h="868680">
                 <a:tc>
@@ -3777,6 +3756,11 @@
                     </a:solidFill>
                   </a:tcPr>
                 </a:tc>
+                <a:extLst>
+                  <a:ext uri="{0D108BD9-81ED-4DB2-BD59-A6C34878D82A}">
+                    <a16:rowId xmlns:a16="http://schemas.microsoft.com/office/drawing/2014/main" val="10000"/>
+                  </a:ext>
+                </a:extLst>
               </a:tr>
               <a:tr h="868680">
                 <a:tc>
@@ -3894,6 +3878,11 @@
                     </a:solidFill>
                   </a:tcPr>
                 </a:tc>
+                <a:extLst>
+                  <a:ext uri="{0D108BD9-81ED-4DB2-BD59-A6C34878D82A}">
+                    <a16:rowId xmlns:a16="http://schemas.microsoft.com/office/drawing/2014/main" val="10001"/>
+                  </a:ext>
+                </a:extLst>
               </a:tr>
               <a:tr h="868680">
                 <a:tc>
@@ -4011,6 +4000,11 @@
                     </a:solidFill>
                   </a:tcPr>
                 </a:tc>
+                <a:extLst>
+                  <a:ext uri="{0D108BD9-81ED-4DB2-BD59-A6C34878D82A}">
+                    <a16:rowId xmlns:a16="http://schemas.microsoft.com/office/drawing/2014/main" val="10002"/>
+                  </a:ext>
+                </a:extLst>
               </a:tr>
               <a:tr h="868680">
                 <a:tc>
@@ -4128,6 +4122,11 @@
                     </a:solidFill>
                   </a:tcPr>
                 </a:tc>
+                <a:extLst>
+                  <a:ext uri="{0D108BD9-81ED-4DB2-BD59-A6C34878D82A}">
+                    <a16:rowId xmlns:a16="http://schemas.microsoft.com/office/drawing/2014/main" val="10003"/>
+                  </a:ext>
+                </a:extLst>
               </a:tr>
             </a:tbl>
           </a:graphicData>
@@ -4142,7 +4141,7 @@
 </file>
 
 <file path=ppt/slides/slide4.xml><?xml version="1.0" encoding="utf-8"?>
-<p:sld xmlns:a="http://schemas.openxmlformats.org/drawingml/2006/main" xmlns:p="http://schemas.openxmlformats.org/presentationml/2006/main" xmlns:r="http://schemas.openxmlformats.org/officeDocument/2006/relationships">
+<p:sld xmlns:a="http://schemas.openxmlformats.org/drawingml/2006/main" xmlns:r="http://schemas.openxmlformats.org/officeDocument/2006/relationships" xmlns:p="http://schemas.openxmlformats.org/presentationml/2006/main">
   <p:cSld>
     <p:bg>
       <p:bgPr>
@@ -4158,7 +4157,14 @@
         <p:cNvGrpSpPr/>
         <p:nvPr/>
       </p:nvGrpSpPr>
-      <p:grpSpPr/>
+      <p:grpSpPr>
+        <a:xfrm>
+          <a:off x="0" y="0"/>
+          <a:ext cx="0" cy="0"/>
+          <a:chOff x="0" y="0"/>
+          <a:chExt cx="0" cy="0"/>
+        </a:xfrm>
+      </p:grpSpPr>
       <p:sp>
         <p:nvSpPr>
           <p:cNvPr id="2" name="TextBox 1"/>
@@ -4381,7 +4387,7 @@
 </file>
 
 <file path=ppt/slides/slide5.xml><?xml version="1.0" encoding="utf-8"?>
-<p:sld xmlns:a="http://schemas.openxmlformats.org/drawingml/2006/main" xmlns:p="http://schemas.openxmlformats.org/presentationml/2006/main" xmlns:r="http://schemas.openxmlformats.org/officeDocument/2006/relationships">
+<p:sld xmlns:a="http://schemas.openxmlformats.org/drawingml/2006/main" xmlns:r="http://schemas.openxmlformats.org/officeDocument/2006/relationships" xmlns:p="http://schemas.openxmlformats.org/presentationml/2006/main">
   <p:cSld>
     <p:bg>
       <p:bgPr>
@@ -4397,7 +4403,14 @@
         <p:cNvGrpSpPr/>
         <p:nvPr/>
       </p:nvGrpSpPr>
-      <p:grpSpPr/>
+      <p:grpSpPr>
+        <a:xfrm>
+          <a:off x="0" y="0"/>
+          <a:ext cx="0" cy="0"/>
+          <a:chOff x="0" y="0"/>
+          <a:chExt cx="0" cy="0"/>
+        </a:xfrm>
+      </p:grpSpPr>
       <p:sp>
         <p:nvSpPr>
           <p:cNvPr id="2" name="TextBox 1"/>
@@ -4597,7 +4610,7 @@
 </file>
 
 <file path=ppt/slides/slide6.xml><?xml version="1.0" encoding="utf-8"?>
-<p:sld xmlns:a="http://schemas.openxmlformats.org/drawingml/2006/main" xmlns:p="http://schemas.openxmlformats.org/presentationml/2006/main" xmlns:r="http://schemas.openxmlformats.org/officeDocument/2006/relationships">
+<p:sld xmlns:a="http://schemas.openxmlformats.org/drawingml/2006/main" xmlns:r="http://schemas.openxmlformats.org/officeDocument/2006/relationships" xmlns:p="http://schemas.openxmlformats.org/presentationml/2006/main">
   <p:cSld>
     <p:bg>
       <p:bgPr>
@@ -4613,7 +4626,14 @@
         <p:cNvGrpSpPr/>
         <p:nvPr/>
       </p:nvGrpSpPr>
-      <p:grpSpPr/>
+      <p:grpSpPr>
+        <a:xfrm>
+          <a:off x="0" y="0"/>
+          <a:ext cx="0" cy="0"/>
+          <a:chOff x="0" y="0"/>
+          <a:chExt cx="0" cy="0"/>
+        </a:xfrm>
+      </p:grpSpPr>
       <p:sp>
         <p:nvSpPr>
           <p:cNvPr id="2" name="TextBox 1"/>

</xml_diff>